<commit_message>
cambios a lo que se tiene el figma
</commit_message>
<xml_diff>
--- a/public/docs/Presentacion para ponencias.pptx
+++ b/public/docs/Presentacion para ponencias.pptx
@@ -4,6 +4,12 @@
   <p:sldMasterIdLst>
     <p:sldMasterId id="2147483648" r:id="rId1"/>
   </p:sldMasterIdLst>
+  <p:notesMasterIdLst>
+    <p:notesMasterId r:id="rId8"/>
+  </p:notesMasterIdLst>
+  <p:handoutMasterIdLst>
+    <p:handoutMasterId r:id="rId9"/>
+  </p:handoutMasterIdLst>
   <p:sldIdLst>
     <p:sldId id="257" r:id="rId2"/>
     <p:sldId id="258" r:id="rId3"/>
@@ -109,7 +115,553 @@
       </a:defRPr>
     </a:lvl9pPr>
   </p:defaultTextStyle>
+  <p:extLst>
+    <p:ext uri="{EFAFB233-063F-42B5-8137-9DF3F51BA10A}">
+      <p15:sldGuideLst xmlns:p15="http://schemas.microsoft.com/office/powerpoint/2012/main"/>
+    </p:ext>
+  </p:extLst>
 </p:presentation>
+</file>
+
+<file path=ppt/handoutMasters/handoutMaster1.xml><?xml version="1.0" encoding="utf-8"?>
+<p:handoutMaster xmlns:a="http://schemas.openxmlformats.org/drawingml/2006/main" xmlns:r="http://schemas.openxmlformats.org/officeDocument/2006/relationships" xmlns:p="http://schemas.openxmlformats.org/presentationml/2006/main">
+  <p:cSld>
+    <p:bg>
+      <p:bgRef idx="1001">
+        <a:schemeClr val="bg1"/>
+      </p:bgRef>
+    </p:bg>
+    <p:spTree>
+      <p:nvGrpSpPr>
+        <p:cNvPr id="1" name=""/>
+        <p:cNvGrpSpPr/>
+        <p:nvPr/>
+      </p:nvGrpSpPr>
+      <p:grpSpPr>
+        <a:xfrm>
+          <a:off x="0" y="0"/>
+          <a:ext cx="0" cy="0"/>
+          <a:chOff x="0" y="0"/>
+          <a:chExt cx="0" cy="0"/>
+        </a:xfrm>
+      </p:grpSpPr>
+      <p:sp>
+        <p:nvSpPr>
+          <p:cNvPr id="2" name="Marcador de encabezado 1">
+            <a:extLst>
+              <a:ext uri="{FF2B5EF4-FFF2-40B4-BE49-F238E27FC236}">
+                <a16:creationId xmlns:a16="http://schemas.microsoft.com/office/drawing/2014/main" id="{D2BBA7B2-3FD4-1248-6A4F-5010CCCEC872}"/>
+              </a:ext>
+            </a:extLst>
+          </p:cNvPr>
+          <p:cNvSpPr>
+            <a:spLocks noGrp="1"/>
+          </p:cNvSpPr>
+          <p:nvPr>
+            <p:ph type="hdr" sz="quarter"/>
+          </p:nvPr>
+        </p:nvSpPr>
+        <p:spPr>
+          <a:xfrm>
+            <a:off x="0" y="0"/>
+            <a:ext cx="2971800" cy="458788"/>
+          </a:xfrm>
+          <a:prstGeom prst="rect">
+            <a:avLst/>
+          </a:prstGeom>
+        </p:spPr>
+        <p:txBody>
+          <a:bodyPr vert="horz" lIns="91440" tIns="45720" rIns="91440" bIns="45720" rtlCol="0"/>
+          <a:lstStyle>
+            <a:lvl1pPr algn="l">
+              <a:defRPr sz="1200"/>
+            </a:lvl1pPr>
+          </a:lstStyle>
+          <a:p>
+            <a:endParaRPr lang="es-EC"/>
+          </a:p>
+        </p:txBody>
+      </p:sp>
+      <p:sp>
+        <p:nvSpPr>
+          <p:cNvPr id="3" name="Marcador de fecha 2">
+            <a:extLst>
+              <a:ext uri="{FF2B5EF4-FFF2-40B4-BE49-F238E27FC236}">
+                <a16:creationId xmlns:a16="http://schemas.microsoft.com/office/drawing/2014/main" id="{E17DB8FD-1267-0B7F-A640-9D164CD0DF50}"/>
+              </a:ext>
+            </a:extLst>
+          </p:cNvPr>
+          <p:cNvSpPr>
+            <a:spLocks noGrp="1"/>
+          </p:cNvSpPr>
+          <p:nvPr>
+            <p:ph type="dt" sz="quarter" idx="1"/>
+          </p:nvPr>
+        </p:nvSpPr>
+        <p:spPr>
+          <a:xfrm>
+            <a:off x="3884613" y="0"/>
+            <a:ext cx="2971800" cy="458788"/>
+          </a:xfrm>
+          <a:prstGeom prst="rect">
+            <a:avLst/>
+          </a:prstGeom>
+        </p:spPr>
+        <p:txBody>
+          <a:bodyPr vert="horz" lIns="91440" tIns="45720" rIns="91440" bIns="45720" rtlCol="0"/>
+          <a:lstStyle>
+            <a:lvl1pPr algn="r">
+              <a:defRPr sz="1200"/>
+            </a:lvl1pPr>
+          </a:lstStyle>
+          <a:p>
+            <a:fld id="{EC3CD132-BF54-41C7-AC00-1015338699B6}" type="datetimeFigureOut">
+              <a:rPr lang="es-EC" smtClean="0"/>
+              <a:t>16/6/2026</a:t>
+            </a:fld>
+            <a:endParaRPr lang="es-EC"/>
+          </a:p>
+        </p:txBody>
+      </p:sp>
+      <p:sp>
+        <p:nvSpPr>
+          <p:cNvPr id="4" name="Marcador de pie de página 3">
+            <a:extLst>
+              <a:ext uri="{FF2B5EF4-FFF2-40B4-BE49-F238E27FC236}">
+                <a16:creationId xmlns:a16="http://schemas.microsoft.com/office/drawing/2014/main" id="{E62667CE-0539-1289-8FFA-11DB408AF10C}"/>
+              </a:ext>
+            </a:extLst>
+          </p:cNvPr>
+          <p:cNvSpPr>
+            <a:spLocks noGrp="1"/>
+          </p:cNvSpPr>
+          <p:nvPr>
+            <p:ph type="ftr" sz="quarter" idx="2"/>
+          </p:nvPr>
+        </p:nvSpPr>
+        <p:spPr>
+          <a:xfrm>
+            <a:off x="0" y="8685213"/>
+            <a:ext cx="2971800" cy="458787"/>
+          </a:xfrm>
+          <a:prstGeom prst="rect">
+            <a:avLst/>
+          </a:prstGeom>
+        </p:spPr>
+        <p:txBody>
+          <a:bodyPr vert="horz" lIns="91440" tIns="45720" rIns="91440" bIns="45720" rtlCol="0" anchor="b"/>
+          <a:lstStyle>
+            <a:lvl1pPr algn="l">
+              <a:defRPr sz="1200"/>
+            </a:lvl1pPr>
+          </a:lstStyle>
+          <a:p>
+            <a:endParaRPr lang="es-EC"/>
+          </a:p>
+        </p:txBody>
+      </p:sp>
+      <p:sp>
+        <p:nvSpPr>
+          <p:cNvPr id="5" name="Marcador de número de diapositiva 4">
+            <a:extLst>
+              <a:ext uri="{FF2B5EF4-FFF2-40B4-BE49-F238E27FC236}">
+                <a16:creationId xmlns:a16="http://schemas.microsoft.com/office/drawing/2014/main" id="{6CBCA62C-1656-9BDB-B254-41F566E72DA0}"/>
+              </a:ext>
+            </a:extLst>
+          </p:cNvPr>
+          <p:cNvSpPr>
+            <a:spLocks noGrp="1"/>
+          </p:cNvSpPr>
+          <p:nvPr>
+            <p:ph type="sldNum" sz="quarter" idx="3"/>
+          </p:nvPr>
+        </p:nvSpPr>
+        <p:spPr>
+          <a:xfrm>
+            <a:off x="3884613" y="8685213"/>
+            <a:ext cx="2971800" cy="458787"/>
+          </a:xfrm>
+          <a:prstGeom prst="rect">
+            <a:avLst/>
+          </a:prstGeom>
+        </p:spPr>
+        <p:txBody>
+          <a:bodyPr vert="horz" lIns="91440" tIns="45720" rIns="91440" bIns="45720" rtlCol="0" anchor="b"/>
+          <a:lstStyle>
+            <a:lvl1pPr algn="r">
+              <a:defRPr sz="1200"/>
+            </a:lvl1pPr>
+          </a:lstStyle>
+          <a:p>
+            <a:fld id="{FDB59BED-FD30-491D-A21C-9873B083DAB1}" type="slidenum">
+              <a:rPr lang="es-EC" smtClean="0"/>
+              <a:t>‹Nº›</a:t>
+            </a:fld>
+            <a:endParaRPr lang="es-EC"/>
+          </a:p>
+        </p:txBody>
+      </p:sp>
+    </p:spTree>
+    <p:extLst>
+      <p:ext uri="{BB962C8B-B14F-4D97-AF65-F5344CB8AC3E}">
+        <p14:creationId xmlns:p14="http://schemas.microsoft.com/office/powerpoint/2010/main" val="2332265744"/>
+      </p:ext>
+    </p:extLst>
+  </p:cSld>
+  <p:clrMap bg1="lt1" tx1="dk1" bg2="lt2" tx2="dk2" accent1="accent1" accent2="accent2" accent3="accent3" accent4="accent4" accent5="accent5" accent6="accent6" hlink="hlink" folHlink="folHlink"/>
+  <p:hf ftr="0" dt="0"/>
+</p:handoutMaster>
+</file>
+
+<file path=ppt/notesMasters/notesMaster1.xml><?xml version="1.0" encoding="utf-8"?>
+<p:notesMaster xmlns:a="http://schemas.openxmlformats.org/drawingml/2006/main" xmlns:r="http://schemas.openxmlformats.org/officeDocument/2006/relationships" xmlns:p="http://schemas.openxmlformats.org/presentationml/2006/main">
+  <p:cSld>
+    <p:bg>
+      <p:bgRef idx="1001">
+        <a:schemeClr val="bg1"/>
+      </p:bgRef>
+    </p:bg>
+    <p:spTree>
+      <p:nvGrpSpPr>
+        <p:cNvPr id="1" name=""/>
+        <p:cNvGrpSpPr/>
+        <p:nvPr/>
+      </p:nvGrpSpPr>
+      <p:grpSpPr>
+        <a:xfrm>
+          <a:off x="0" y="0"/>
+          <a:ext cx="0" cy="0"/>
+          <a:chOff x="0" y="0"/>
+          <a:chExt cx="0" cy="0"/>
+        </a:xfrm>
+      </p:grpSpPr>
+      <p:sp>
+        <p:nvSpPr>
+          <p:cNvPr id="2" name="Marcador de encabezado 1"/>
+          <p:cNvSpPr>
+            <a:spLocks noGrp="1"/>
+          </p:cNvSpPr>
+          <p:nvPr>
+            <p:ph type="hdr" sz="quarter"/>
+          </p:nvPr>
+        </p:nvSpPr>
+        <p:spPr>
+          <a:xfrm>
+            <a:off x="0" y="0"/>
+            <a:ext cx="2971800" cy="458788"/>
+          </a:xfrm>
+          <a:prstGeom prst="rect">
+            <a:avLst/>
+          </a:prstGeom>
+        </p:spPr>
+        <p:txBody>
+          <a:bodyPr vert="horz" lIns="91440" tIns="45720" rIns="91440" bIns="45720" rtlCol="0"/>
+          <a:lstStyle>
+            <a:lvl1pPr algn="l">
+              <a:defRPr sz="1200"/>
+            </a:lvl1pPr>
+          </a:lstStyle>
+          <a:p>
+            <a:endParaRPr lang="es-EC"/>
+          </a:p>
+        </p:txBody>
+      </p:sp>
+      <p:sp>
+        <p:nvSpPr>
+          <p:cNvPr id="3" name="Marcador de fecha 2"/>
+          <p:cNvSpPr>
+            <a:spLocks noGrp="1"/>
+          </p:cNvSpPr>
+          <p:nvPr>
+            <p:ph type="dt" idx="1"/>
+          </p:nvPr>
+        </p:nvSpPr>
+        <p:spPr>
+          <a:xfrm>
+            <a:off x="3884613" y="0"/>
+            <a:ext cx="2971800" cy="458788"/>
+          </a:xfrm>
+          <a:prstGeom prst="rect">
+            <a:avLst/>
+          </a:prstGeom>
+        </p:spPr>
+        <p:txBody>
+          <a:bodyPr vert="horz" lIns="91440" tIns="45720" rIns="91440" bIns="45720" rtlCol="0"/>
+          <a:lstStyle>
+            <a:lvl1pPr algn="r">
+              <a:defRPr sz="1200"/>
+            </a:lvl1pPr>
+          </a:lstStyle>
+          <a:p>
+            <a:fld id="{38E5C2EB-B4E2-4DBB-835F-A5B967E10610}" type="datetimeFigureOut">
+              <a:rPr lang="es-EC" smtClean="0"/>
+              <a:t>16/6/2026</a:t>
+            </a:fld>
+            <a:endParaRPr lang="es-EC"/>
+          </a:p>
+        </p:txBody>
+      </p:sp>
+      <p:sp>
+        <p:nvSpPr>
+          <p:cNvPr id="4" name="Marcador de imagen de diapositiva 3"/>
+          <p:cNvSpPr>
+            <a:spLocks noGrp="1" noRot="1" noChangeAspect="1"/>
+          </p:cNvSpPr>
+          <p:nvPr>
+            <p:ph type="sldImg" idx="2"/>
+          </p:nvPr>
+        </p:nvSpPr>
+        <p:spPr>
+          <a:xfrm>
+            <a:off x="685800" y="1143000"/>
+            <a:ext cx="5486400" cy="3086100"/>
+          </a:xfrm>
+          <a:prstGeom prst="rect">
+            <a:avLst/>
+          </a:prstGeom>
+          <a:noFill/>
+          <a:ln w="12700">
+            <a:solidFill>
+              <a:prstClr val="black"/>
+            </a:solidFill>
+          </a:ln>
+        </p:spPr>
+        <p:txBody>
+          <a:bodyPr vert="horz" lIns="91440" tIns="45720" rIns="91440" bIns="45720" rtlCol="0" anchor="ctr"/>
+          <a:lstStyle/>
+          <a:p>
+            <a:endParaRPr lang="es-EC"/>
+          </a:p>
+        </p:txBody>
+      </p:sp>
+      <p:sp>
+        <p:nvSpPr>
+          <p:cNvPr id="5" name="Marcador de notas 4"/>
+          <p:cNvSpPr>
+            <a:spLocks noGrp="1"/>
+          </p:cNvSpPr>
+          <p:nvPr>
+            <p:ph type="body" sz="quarter" idx="3"/>
+          </p:nvPr>
+        </p:nvSpPr>
+        <p:spPr>
+          <a:xfrm>
+            <a:off x="685800" y="4400550"/>
+            <a:ext cx="5486400" cy="3600450"/>
+          </a:xfrm>
+          <a:prstGeom prst="rect">
+            <a:avLst/>
+          </a:prstGeom>
+        </p:spPr>
+        <p:txBody>
+          <a:bodyPr vert="horz" lIns="91440" tIns="45720" rIns="91440" bIns="45720" rtlCol="0"/>
+          <a:lstStyle/>
+          <a:p>
+            <a:pPr lvl="0"/>
+            <a:r>
+              <a:rPr lang="es-ES"/>
+              <a:t>Haga clic para modificar los estilos de texto del patrón</a:t>
+            </a:r>
+          </a:p>
+          <a:p>
+            <a:pPr lvl="1"/>
+            <a:r>
+              <a:rPr lang="es-ES"/>
+              <a:t>Segundo nivel</a:t>
+            </a:r>
+          </a:p>
+          <a:p>
+            <a:pPr lvl="2"/>
+            <a:r>
+              <a:rPr lang="es-ES"/>
+              <a:t>Tercer nivel</a:t>
+            </a:r>
+          </a:p>
+          <a:p>
+            <a:pPr lvl="3"/>
+            <a:r>
+              <a:rPr lang="es-ES"/>
+              <a:t>Cuarto nivel</a:t>
+            </a:r>
+          </a:p>
+          <a:p>
+            <a:pPr lvl="4"/>
+            <a:r>
+              <a:rPr lang="es-ES"/>
+              <a:t>Quinto nivel</a:t>
+            </a:r>
+            <a:endParaRPr lang="es-EC"/>
+          </a:p>
+        </p:txBody>
+      </p:sp>
+      <p:sp>
+        <p:nvSpPr>
+          <p:cNvPr id="6" name="Marcador de pie de página 5"/>
+          <p:cNvSpPr>
+            <a:spLocks noGrp="1"/>
+          </p:cNvSpPr>
+          <p:nvPr>
+            <p:ph type="ftr" sz="quarter" idx="4"/>
+          </p:nvPr>
+        </p:nvSpPr>
+        <p:spPr>
+          <a:xfrm>
+            <a:off x="0" y="8685213"/>
+            <a:ext cx="2971800" cy="458787"/>
+          </a:xfrm>
+          <a:prstGeom prst="rect">
+            <a:avLst/>
+          </a:prstGeom>
+        </p:spPr>
+        <p:txBody>
+          <a:bodyPr vert="horz" lIns="91440" tIns="45720" rIns="91440" bIns="45720" rtlCol="0" anchor="b"/>
+          <a:lstStyle>
+            <a:lvl1pPr algn="l">
+              <a:defRPr sz="1200"/>
+            </a:lvl1pPr>
+          </a:lstStyle>
+          <a:p>
+            <a:endParaRPr lang="es-EC"/>
+          </a:p>
+        </p:txBody>
+      </p:sp>
+      <p:sp>
+        <p:nvSpPr>
+          <p:cNvPr id="7" name="Marcador de número de diapositiva 6"/>
+          <p:cNvSpPr>
+            <a:spLocks noGrp="1"/>
+          </p:cNvSpPr>
+          <p:nvPr>
+            <p:ph type="sldNum" sz="quarter" idx="5"/>
+          </p:nvPr>
+        </p:nvSpPr>
+        <p:spPr>
+          <a:xfrm>
+            <a:off x="3884613" y="8685213"/>
+            <a:ext cx="2971800" cy="458787"/>
+          </a:xfrm>
+          <a:prstGeom prst="rect">
+            <a:avLst/>
+          </a:prstGeom>
+        </p:spPr>
+        <p:txBody>
+          <a:bodyPr vert="horz" lIns="91440" tIns="45720" rIns="91440" bIns="45720" rtlCol="0" anchor="b"/>
+          <a:lstStyle>
+            <a:lvl1pPr algn="r">
+              <a:defRPr sz="1200"/>
+            </a:lvl1pPr>
+          </a:lstStyle>
+          <a:p>
+            <a:fld id="{8023B87D-859C-4F75-AD12-33913A0AE8AF}" type="slidenum">
+              <a:rPr lang="es-EC" smtClean="0"/>
+              <a:t>‹Nº›</a:t>
+            </a:fld>
+            <a:endParaRPr lang="es-EC"/>
+          </a:p>
+        </p:txBody>
+      </p:sp>
+    </p:spTree>
+    <p:extLst>
+      <p:ext uri="{BB962C8B-B14F-4D97-AF65-F5344CB8AC3E}">
+        <p14:creationId xmlns:p14="http://schemas.microsoft.com/office/powerpoint/2010/main" val="415262154"/>
+      </p:ext>
+    </p:extLst>
+  </p:cSld>
+  <p:clrMap bg1="lt1" tx1="dk1" bg2="lt2" tx2="dk2" accent1="accent1" accent2="accent2" accent3="accent3" accent4="accent4" accent5="accent5" accent6="accent6" hlink="hlink" folHlink="folHlink"/>
+  <p:hf ftr="0" dt="0"/>
+  <p:notesStyle>
+    <a:lvl1pPr marL="0" algn="l" defTabSz="914400" rtl="0" eaLnBrk="1" latinLnBrk="0" hangingPunct="1">
+      <a:defRPr sz="1200" kern="1200">
+        <a:solidFill>
+          <a:schemeClr val="tx1"/>
+        </a:solidFill>
+        <a:latin typeface="+mn-lt"/>
+        <a:ea typeface="+mn-ea"/>
+        <a:cs typeface="+mn-cs"/>
+      </a:defRPr>
+    </a:lvl1pPr>
+    <a:lvl2pPr marL="457200" algn="l" defTabSz="914400" rtl="0" eaLnBrk="1" latinLnBrk="0" hangingPunct="1">
+      <a:defRPr sz="1200" kern="1200">
+        <a:solidFill>
+          <a:schemeClr val="tx1"/>
+        </a:solidFill>
+        <a:latin typeface="+mn-lt"/>
+        <a:ea typeface="+mn-ea"/>
+        <a:cs typeface="+mn-cs"/>
+      </a:defRPr>
+    </a:lvl2pPr>
+    <a:lvl3pPr marL="914400" algn="l" defTabSz="914400" rtl="0" eaLnBrk="1" latinLnBrk="0" hangingPunct="1">
+      <a:defRPr sz="1200" kern="1200">
+        <a:solidFill>
+          <a:schemeClr val="tx1"/>
+        </a:solidFill>
+        <a:latin typeface="+mn-lt"/>
+        <a:ea typeface="+mn-ea"/>
+        <a:cs typeface="+mn-cs"/>
+      </a:defRPr>
+    </a:lvl3pPr>
+    <a:lvl4pPr marL="1371600" algn="l" defTabSz="914400" rtl="0" eaLnBrk="1" latinLnBrk="0" hangingPunct="1">
+      <a:defRPr sz="1200" kern="1200">
+        <a:solidFill>
+          <a:schemeClr val="tx1"/>
+        </a:solidFill>
+        <a:latin typeface="+mn-lt"/>
+        <a:ea typeface="+mn-ea"/>
+        <a:cs typeface="+mn-cs"/>
+      </a:defRPr>
+    </a:lvl4pPr>
+    <a:lvl5pPr marL="1828800" algn="l" defTabSz="914400" rtl="0" eaLnBrk="1" latinLnBrk="0" hangingPunct="1">
+      <a:defRPr sz="1200" kern="1200">
+        <a:solidFill>
+          <a:schemeClr val="tx1"/>
+        </a:solidFill>
+        <a:latin typeface="+mn-lt"/>
+        <a:ea typeface="+mn-ea"/>
+        <a:cs typeface="+mn-cs"/>
+      </a:defRPr>
+    </a:lvl5pPr>
+    <a:lvl6pPr marL="2286000" algn="l" defTabSz="914400" rtl="0" eaLnBrk="1" latinLnBrk="0" hangingPunct="1">
+      <a:defRPr sz="1200" kern="1200">
+        <a:solidFill>
+          <a:schemeClr val="tx1"/>
+        </a:solidFill>
+        <a:latin typeface="+mn-lt"/>
+        <a:ea typeface="+mn-ea"/>
+        <a:cs typeface="+mn-cs"/>
+      </a:defRPr>
+    </a:lvl6pPr>
+    <a:lvl7pPr marL="2743200" algn="l" defTabSz="914400" rtl="0" eaLnBrk="1" latinLnBrk="0" hangingPunct="1">
+      <a:defRPr sz="1200" kern="1200">
+        <a:solidFill>
+          <a:schemeClr val="tx1"/>
+        </a:solidFill>
+        <a:latin typeface="+mn-lt"/>
+        <a:ea typeface="+mn-ea"/>
+        <a:cs typeface="+mn-cs"/>
+      </a:defRPr>
+    </a:lvl7pPr>
+    <a:lvl8pPr marL="3200400" algn="l" defTabSz="914400" rtl="0" eaLnBrk="1" latinLnBrk="0" hangingPunct="1">
+      <a:defRPr sz="1200" kern="1200">
+        <a:solidFill>
+          <a:schemeClr val="tx1"/>
+        </a:solidFill>
+        <a:latin typeface="+mn-lt"/>
+        <a:ea typeface="+mn-ea"/>
+        <a:cs typeface="+mn-cs"/>
+      </a:defRPr>
+    </a:lvl8pPr>
+    <a:lvl9pPr marL="3657600" algn="l" defTabSz="914400" rtl="0" eaLnBrk="1" latinLnBrk="0" hangingPunct="1">
+      <a:defRPr sz="1200" kern="1200">
+        <a:solidFill>
+          <a:schemeClr val="tx1"/>
+        </a:solidFill>
+        <a:latin typeface="+mn-lt"/>
+        <a:ea typeface="+mn-ea"/>
+        <a:cs typeface="+mn-cs"/>
+      </a:defRPr>
+    </a:lvl9pPr>
+  </p:notesStyle>
+</p:notesMaster>
 </file>
 
 <file path=ppt/slideLayouts/slideLayout1.xml><?xml version="1.0" encoding="utf-8"?>
@@ -261,7 +813,7 @@
           <a:p>
             <a:fld id="{29413588-A073-483C-926A-0312EB53A3B6}" type="datetimeFigureOut">
               <a:rPr lang="es-EC" smtClean="0"/>
-              <a:t>4/2/2026</a:t>
+              <a:t>16/6/2026</a:t>
             </a:fld>
             <a:endParaRPr lang="es-EC"/>
           </a:p>
@@ -461,7 +1013,7 @@
           <a:p>
             <a:fld id="{29413588-A073-483C-926A-0312EB53A3B6}" type="datetimeFigureOut">
               <a:rPr lang="es-EC" smtClean="0"/>
-              <a:t>4/2/2026</a:t>
+              <a:t>16/6/2026</a:t>
             </a:fld>
             <a:endParaRPr lang="es-EC"/>
           </a:p>
@@ -671,7 +1223,7 @@
           <a:p>
             <a:fld id="{29413588-A073-483C-926A-0312EB53A3B6}" type="datetimeFigureOut">
               <a:rPr lang="es-EC" smtClean="0"/>
-              <a:t>4/2/2026</a:t>
+              <a:t>16/6/2026</a:t>
             </a:fld>
             <a:endParaRPr lang="es-EC"/>
           </a:p>
@@ -871,7 +1423,7 @@
           <a:p>
             <a:fld id="{29413588-A073-483C-926A-0312EB53A3B6}" type="datetimeFigureOut">
               <a:rPr lang="es-EC" smtClean="0"/>
-              <a:t>4/2/2026</a:t>
+              <a:t>16/6/2026</a:t>
             </a:fld>
             <a:endParaRPr lang="es-EC"/>
           </a:p>
@@ -1147,7 +1699,7 @@
           <a:p>
             <a:fld id="{29413588-A073-483C-926A-0312EB53A3B6}" type="datetimeFigureOut">
               <a:rPr lang="es-EC" smtClean="0"/>
-              <a:t>4/2/2026</a:t>
+              <a:t>16/6/2026</a:t>
             </a:fld>
             <a:endParaRPr lang="es-EC"/>
           </a:p>
@@ -1415,7 +1967,7 @@
           <a:p>
             <a:fld id="{29413588-A073-483C-926A-0312EB53A3B6}" type="datetimeFigureOut">
               <a:rPr lang="es-EC" smtClean="0"/>
-              <a:t>4/2/2026</a:t>
+              <a:t>16/6/2026</a:t>
             </a:fld>
             <a:endParaRPr lang="es-EC"/>
           </a:p>
@@ -1830,7 +2382,7 @@
           <a:p>
             <a:fld id="{29413588-A073-483C-926A-0312EB53A3B6}" type="datetimeFigureOut">
               <a:rPr lang="es-EC" smtClean="0"/>
-              <a:t>4/2/2026</a:t>
+              <a:t>16/6/2026</a:t>
             </a:fld>
             <a:endParaRPr lang="es-EC"/>
           </a:p>
@@ -1972,7 +2524,7 @@
           <a:p>
             <a:fld id="{29413588-A073-483C-926A-0312EB53A3B6}" type="datetimeFigureOut">
               <a:rPr lang="es-EC" smtClean="0"/>
-              <a:t>4/2/2026</a:t>
+              <a:t>16/6/2026</a:t>
             </a:fld>
             <a:endParaRPr lang="es-EC"/>
           </a:p>
@@ -2085,7 +2637,7 @@
           <a:p>
             <a:fld id="{29413588-A073-483C-926A-0312EB53A3B6}" type="datetimeFigureOut">
               <a:rPr lang="es-EC" smtClean="0"/>
-              <a:t>4/2/2026</a:t>
+              <a:t>16/6/2026</a:t>
             </a:fld>
             <a:endParaRPr lang="es-EC"/>
           </a:p>
@@ -2398,7 +2950,7 @@
           <a:p>
             <a:fld id="{29413588-A073-483C-926A-0312EB53A3B6}" type="datetimeFigureOut">
               <a:rPr lang="es-EC" smtClean="0"/>
-              <a:t>4/2/2026</a:t>
+              <a:t>16/6/2026</a:t>
             </a:fld>
             <a:endParaRPr lang="es-EC"/>
           </a:p>
@@ -2687,7 +3239,7 @@
           <a:p>
             <a:fld id="{29413588-A073-483C-926A-0312EB53A3B6}" type="datetimeFigureOut">
               <a:rPr lang="es-EC" smtClean="0"/>
-              <a:t>4/2/2026</a:t>
+              <a:t>16/6/2026</a:t>
             </a:fld>
             <a:endParaRPr lang="es-EC"/>
           </a:p>
@@ -2930,7 +3482,7 @@
           <a:p>
             <a:fld id="{29413588-A073-483C-926A-0312EB53A3B6}" type="datetimeFigureOut">
               <a:rPr lang="es-EC" smtClean="0"/>
-              <a:t>4/2/2026</a:t>
+              <a:t>16/6/2026</a:t>
             </a:fld>
             <a:endParaRPr lang="es-EC"/>
           </a:p>
@@ -3380,7 +3932,7 @@
           <a:lstStyle/>
           <a:p>
             <a:r>
-              <a:rPr lang="es-ES" dirty="0"/>
+              <a:rPr lang="es-ES"/>
               <a:t>Titulo Ponencia</a:t>
             </a:r>
             <a:endParaRPr lang="es-EC" dirty="0"/>
@@ -3409,7 +3961,7 @@
           <a:lstStyle/>
           <a:p>
             <a:r>
-              <a:rPr lang="es-ES" dirty="0"/>
+              <a:rPr lang="es-ES"/>
               <a:t>Autor o Autores</a:t>
             </a:r>
             <a:endParaRPr lang="es-EC" dirty="0"/>
@@ -3418,10 +3970,10 @@
       </p:sp>
       <p:pic>
         <p:nvPicPr>
-          <p:cNvPr id="5" name="Imagen 4" descr="Fondo negro con letras blancas&#10;&#10;El contenido generado por IA puede ser incorrecto.">
-            <a:extLst>
-              <a:ext uri="{FF2B5EF4-FFF2-40B4-BE49-F238E27FC236}">
-                <a16:creationId xmlns:a16="http://schemas.microsoft.com/office/drawing/2014/main" id="{CDC1EE1E-8DB1-5594-F99B-722780D9CFF2}"/>
+          <p:cNvPr id="8" name="Imagen 7">
+            <a:extLst>
+              <a:ext uri="{FF2B5EF4-FFF2-40B4-BE49-F238E27FC236}">
+                <a16:creationId xmlns:a16="http://schemas.microsoft.com/office/drawing/2014/main" id="{DF73A104-4EC4-5BF2-053C-9B708222DFC8}"/>
               </a:ext>
             </a:extLst>
           </p:cNvPr>
@@ -3438,15 +3990,14 @@
               </a:ext>
             </a:extLst>
           </a:blip>
-          <a:srcRect t="13584" b="35196"/>
           <a:stretch>
             <a:fillRect/>
           </a:stretch>
         </p:blipFill>
         <p:spPr>
           <a:xfrm>
-            <a:off x="0" y="0"/>
-            <a:ext cx="12192000" cy="1571952"/>
+            <a:off x="0" y="-11788"/>
+            <a:ext cx="12192000" cy="1611988"/>
           </a:xfrm>
           <a:prstGeom prst="rect">
             <a:avLst/>
@@ -3455,10 +4006,10 @@
       </p:pic>
       <p:pic>
         <p:nvPicPr>
-          <p:cNvPr id="7" name="Imagen 6" descr="Interfaz de usuario gráfica&#10;&#10;El contenido generado por IA puede ser incorrecto.">
-            <a:extLst>
-              <a:ext uri="{FF2B5EF4-FFF2-40B4-BE49-F238E27FC236}">
-                <a16:creationId xmlns:a16="http://schemas.microsoft.com/office/drawing/2014/main" id="{B75CB716-FCD5-5EBD-D283-8A6B6F23A955}"/>
+          <p:cNvPr id="11" name="Imagen 10">
+            <a:extLst>
+              <a:ext uri="{FF2B5EF4-FFF2-40B4-BE49-F238E27FC236}">
+                <a16:creationId xmlns:a16="http://schemas.microsoft.com/office/drawing/2014/main" id="{20304261-823F-A8B4-64BC-39F07F0888DE}"/>
               </a:ext>
             </a:extLst>
           </p:cNvPr>
@@ -3470,51 +4021,28 @@
         <p:blipFill>
           <a:blip r:embed="rId3">
             <a:extLst>
+              <a:ext uri="{BEBA8EAE-BF5A-486C-A8C5-ECC9F3942E4B}">
+                <a14:imgProps xmlns:a14="http://schemas.microsoft.com/office/drawing/2010/main">
+                  <a14:imgLayer r:embed="rId4">
+                    <a14:imgEffect>
+                      <a14:colorTemperature colorTemp="4700"/>
+                    </a14:imgEffect>
+                  </a14:imgLayer>
+                </a14:imgProps>
+              </a:ext>
               <a:ext uri="{28A0092B-C50C-407E-A947-70E740481C1C}">
                 <a14:useLocalDpi xmlns:a14="http://schemas.microsoft.com/office/drawing/2010/main" val="0"/>
               </a:ext>
             </a:extLst>
           </a:blip>
-          <a:srcRect t="73915"/>
           <a:stretch>
             <a:fillRect/>
           </a:stretch>
         </p:blipFill>
         <p:spPr>
           <a:xfrm>
-            <a:off x="0" y="5928527"/>
-            <a:ext cx="12192000" cy="929473"/>
-          </a:xfrm>
-          <a:prstGeom prst="rect">
-            <a:avLst/>
-          </a:prstGeom>
-        </p:spPr>
-      </p:pic>
-      <p:pic>
-        <p:nvPicPr>
-          <p:cNvPr id="10" name="Imagen 9" descr="Interfaz de usuario gráfica&#10;&#10;El contenido generado por IA puede ser incorrecto.">
-            <a:extLst>
-              <a:ext uri="{FF2B5EF4-FFF2-40B4-BE49-F238E27FC236}">
-                <a16:creationId xmlns:a16="http://schemas.microsoft.com/office/drawing/2014/main" id="{731DBBE8-617A-26F1-6893-417955F98CA8}"/>
-              </a:ext>
-            </a:extLst>
-          </p:cNvPr>
-          <p:cNvPicPr>
-            <a:picLocks noChangeAspect="1"/>
-          </p:cNvPicPr>
-          <p:nvPr/>
-        </p:nvPicPr>
-        <p:blipFill>
-          <a:blip r:embed="rId4"/>
-          <a:srcRect t="12661"/>
-          <a:stretch>
-            <a:fillRect/>
-          </a:stretch>
-        </p:blipFill>
-        <p:spPr>
-          <a:xfrm>
-            <a:off x="8832106" y="46298"/>
-            <a:ext cx="2788875" cy="1038024"/>
+            <a:off x="0" y="5349874"/>
+            <a:ext cx="12192000" cy="1508125"/>
           </a:xfrm>
           <a:prstGeom prst="rect">
             <a:avLst/>
@@ -3631,10 +4159,10 @@
       </p:sp>
       <p:pic>
         <p:nvPicPr>
-          <p:cNvPr id="5" name="Imagen 4" descr="Fondo negro con letras blancas&#10;&#10;El contenido generado por IA puede ser incorrecto.">
-            <a:extLst>
-              <a:ext uri="{FF2B5EF4-FFF2-40B4-BE49-F238E27FC236}">
-                <a16:creationId xmlns:a16="http://schemas.microsoft.com/office/drawing/2014/main" id="{844C796F-37F6-E098-2F40-72666C2BB81F}"/>
+          <p:cNvPr id="6" name="Imagen 5">
+            <a:extLst>
+              <a:ext uri="{FF2B5EF4-FFF2-40B4-BE49-F238E27FC236}">
+                <a16:creationId xmlns:a16="http://schemas.microsoft.com/office/drawing/2014/main" id="{FF1CB032-4270-8C86-4561-FE1D54FC2481}"/>
               </a:ext>
             </a:extLst>
           </p:cNvPr>
@@ -3651,83 +4179,14 @@
               </a:ext>
             </a:extLst>
           </a:blip>
-          <a:srcRect t="13584" b="35196"/>
           <a:stretch>
             <a:fillRect/>
           </a:stretch>
         </p:blipFill>
         <p:spPr>
           <a:xfrm>
-            <a:off x="0" y="0"/>
-            <a:ext cx="12192000" cy="1571952"/>
-          </a:xfrm>
-          <a:prstGeom prst="rect">
-            <a:avLst/>
-          </a:prstGeom>
-        </p:spPr>
-      </p:pic>
-      <p:pic>
-        <p:nvPicPr>
-          <p:cNvPr id="7" name="Imagen 6" descr="Interfaz de usuario gráfica&#10;&#10;El contenido generado por IA puede ser incorrecto.">
-            <a:extLst>
-              <a:ext uri="{FF2B5EF4-FFF2-40B4-BE49-F238E27FC236}">
-                <a16:creationId xmlns:a16="http://schemas.microsoft.com/office/drawing/2014/main" id="{0437CE8D-CA90-D31C-FE90-05A14D17A05D}"/>
-              </a:ext>
-            </a:extLst>
-          </p:cNvPr>
-          <p:cNvPicPr>
-            <a:picLocks noChangeAspect="1"/>
-          </p:cNvPicPr>
-          <p:nvPr/>
-        </p:nvPicPr>
-        <p:blipFill>
-          <a:blip r:embed="rId3">
-            <a:extLst>
-              <a:ext uri="{28A0092B-C50C-407E-A947-70E740481C1C}">
-                <a14:useLocalDpi xmlns:a14="http://schemas.microsoft.com/office/drawing/2010/main" val="0"/>
-              </a:ext>
-            </a:extLst>
-          </a:blip>
-          <a:srcRect t="73915"/>
-          <a:stretch>
-            <a:fillRect/>
-          </a:stretch>
-        </p:blipFill>
-        <p:spPr>
-          <a:xfrm>
-            <a:off x="0" y="5928527"/>
-            <a:ext cx="12192000" cy="929473"/>
-          </a:xfrm>
-          <a:prstGeom prst="rect">
-            <a:avLst/>
-          </a:prstGeom>
-        </p:spPr>
-      </p:pic>
-      <p:pic>
-        <p:nvPicPr>
-          <p:cNvPr id="10" name="Imagen 9" descr="Interfaz de usuario gráfica&#10;&#10;El contenido generado por IA puede ser incorrecto.">
-            <a:extLst>
-              <a:ext uri="{FF2B5EF4-FFF2-40B4-BE49-F238E27FC236}">
-                <a16:creationId xmlns:a16="http://schemas.microsoft.com/office/drawing/2014/main" id="{B447F08F-E09B-88B9-CABA-AA2C9C7978EC}"/>
-              </a:ext>
-            </a:extLst>
-          </p:cNvPr>
-          <p:cNvPicPr>
-            <a:picLocks noChangeAspect="1"/>
-          </p:cNvPicPr>
-          <p:nvPr/>
-        </p:nvPicPr>
-        <p:blipFill>
-          <a:blip r:embed="rId4"/>
-          <a:srcRect t="12661"/>
-          <a:stretch>
-            <a:fillRect/>
-          </a:stretch>
-        </p:blipFill>
-        <p:spPr>
-          <a:xfrm>
-            <a:off x="8832106" y="46298"/>
-            <a:ext cx="2788875" cy="1038024"/>
+            <a:off x="0" y="-11788"/>
+            <a:ext cx="12192000" cy="1611988"/>
           </a:xfrm>
           <a:prstGeom prst="rect">
             <a:avLst/>
@@ -3770,111 +4229,6 @@
           <a:chExt cx="0" cy="0"/>
         </a:xfrm>
       </p:grpSpPr>
-      <p:pic>
-        <p:nvPicPr>
-          <p:cNvPr id="5" name="Imagen 4" descr="Fondo negro con letras blancas&#10;&#10;El contenido generado por IA puede ser incorrecto.">
-            <a:extLst>
-              <a:ext uri="{FF2B5EF4-FFF2-40B4-BE49-F238E27FC236}">
-                <a16:creationId xmlns:a16="http://schemas.microsoft.com/office/drawing/2014/main" id="{0DB4D469-E0A9-B97A-10D4-153E890DC71B}"/>
-              </a:ext>
-            </a:extLst>
-          </p:cNvPr>
-          <p:cNvPicPr>
-            <a:picLocks noChangeAspect="1"/>
-          </p:cNvPicPr>
-          <p:nvPr/>
-        </p:nvPicPr>
-        <p:blipFill>
-          <a:blip r:embed="rId2">
-            <a:extLst>
-              <a:ext uri="{28A0092B-C50C-407E-A947-70E740481C1C}">
-                <a14:useLocalDpi xmlns:a14="http://schemas.microsoft.com/office/drawing/2010/main" val="0"/>
-              </a:ext>
-            </a:extLst>
-          </a:blip>
-          <a:srcRect t="13584" b="35196"/>
-          <a:stretch>
-            <a:fillRect/>
-          </a:stretch>
-        </p:blipFill>
-        <p:spPr>
-          <a:xfrm>
-            <a:off x="0" y="0"/>
-            <a:ext cx="12192000" cy="1571952"/>
-          </a:xfrm>
-          <a:prstGeom prst="rect">
-            <a:avLst/>
-          </a:prstGeom>
-        </p:spPr>
-      </p:pic>
-      <p:pic>
-        <p:nvPicPr>
-          <p:cNvPr id="7" name="Imagen 6" descr="Interfaz de usuario gráfica&#10;&#10;El contenido generado por IA puede ser incorrecto.">
-            <a:extLst>
-              <a:ext uri="{FF2B5EF4-FFF2-40B4-BE49-F238E27FC236}">
-                <a16:creationId xmlns:a16="http://schemas.microsoft.com/office/drawing/2014/main" id="{A495C837-1C1F-432C-C89A-A8E81A4BB397}"/>
-              </a:ext>
-            </a:extLst>
-          </p:cNvPr>
-          <p:cNvPicPr>
-            <a:picLocks noChangeAspect="1"/>
-          </p:cNvPicPr>
-          <p:nvPr/>
-        </p:nvPicPr>
-        <p:blipFill>
-          <a:blip r:embed="rId3">
-            <a:extLst>
-              <a:ext uri="{28A0092B-C50C-407E-A947-70E740481C1C}">
-                <a14:useLocalDpi xmlns:a14="http://schemas.microsoft.com/office/drawing/2010/main" val="0"/>
-              </a:ext>
-            </a:extLst>
-          </a:blip>
-          <a:srcRect t="73915"/>
-          <a:stretch>
-            <a:fillRect/>
-          </a:stretch>
-        </p:blipFill>
-        <p:spPr>
-          <a:xfrm>
-            <a:off x="0" y="5928527"/>
-            <a:ext cx="12192000" cy="929473"/>
-          </a:xfrm>
-          <a:prstGeom prst="rect">
-            <a:avLst/>
-          </a:prstGeom>
-        </p:spPr>
-      </p:pic>
-      <p:pic>
-        <p:nvPicPr>
-          <p:cNvPr id="10" name="Imagen 9" descr="Interfaz de usuario gráfica&#10;&#10;El contenido generado por IA puede ser incorrecto.">
-            <a:extLst>
-              <a:ext uri="{FF2B5EF4-FFF2-40B4-BE49-F238E27FC236}">
-                <a16:creationId xmlns:a16="http://schemas.microsoft.com/office/drawing/2014/main" id="{DAA90A9C-9CEF-45E9-AB3E-7786AE758D04}"/>
-              </a:ext>
-            </a:extLst>
-          </p:cNvPr>
-          <p:cNvPicPr>
-            <a:picLocks noChangeAspect="1"/>
-          </p:cNvPicPr>
-          <p:nvPr/>
-        </p:nvPicPr>
-        <p:blipFill>
-          <a:blip r:embed="rId4"/>
-          <a:srcRect t="12661"/>
-          <a:stretch>
-            <a:fillRect/>
-          </a:stretch>
-        </p:blipFill>
-        <p:spPr>
-          <a:xfrm>
-            <a:off x="8832106" y="46298"/>
-            <a:ext cx="2788875" cy="1038024"/>
-          </a:xfrm>
-          <a:prstGeom prst="rect">
-            <a:avLst/>
-          </a:prstGeom>
-        </p:spPr>
-      </p:pic>
       <p:sp>
         <p:nvSpPr>
           <p:cNvPr id="6" name="Título 1">
@@ -4353,6 +4707,42 @@
           </a:p>
         </p:txBody>
       </p:sp>
+      <p:pic>
+        <p:nvPicPr>
+          <p:cNvPr id="3" name="Imagen 2">
+            <a:extLst>
+              <a:ext uri="{FF2B5EF4-FFF2-40B4-BE49-F238E27FC236}">
+                <a16:creationId xmlns:a16="http://schemas.microsoft.com/office/drawing/2014/main" id="{817FBFC3-2487-3D5B-A425-39F79DA5A720}"/>
+              </a:ext>
+            </a:extLst>
+          </p:cNvPr>
+          <p:cNvPicPr>
+            <a:picLocks noChangeAspect="1"/>
+          </p:cNvPicPr>
+          <p:nvPr/>
+        </p:nvPicPr>
+        <p:blipFill>
+          <a:blip r:embed="rId2">
+            <a:extLst>
+              <a:ext uri="{28A0092B-C50C-407E-A947-70E740481C1C}">
+                <a14:useLocalDpi xmlns:a14="http://schemas.microsoft.com/office/drawing/2010/main" val="0"/>
+              </a:ext>
+            </a:extLst>
+          </a:blip>
+          <a:stretch>
+            <a:fillRect/>
+          </a:stretch>
+        </p:blipFill>
+        <p:spPr>
+          <a:xfrm>
+            <a:off x="-1" y="-4071"/>
+            <a:ext cx="12192000" cy="1611988"/>
+          </a:xfrm>
+          <a:prstGeom prst="rect">
+            <a:avLst/>
+          </a:prstGeom>
+        </p:spPr>
+      </p:pic>
     </p:spTree>
     <p:extLst>
       <p:ext uri="{BB962C8B-B14F-4D97-AF65-F5344CB8AC3E}">
@@ -4446,10 +4836,10 @@
       </p:sp>
       <p:pic>
         <p:nvPicPr>
-          <p:cNvPr id="5" name="Imagen 4" descr="Fondo negro con letras blancas&#10;&#10;El contenido generado por IA puede ser incorrecto.">
-            <a:extLst>
-              <a:ext uri="{FF2B5EF4-FFF2-40B4-BE49-F238E27FC236}">
-                <a16:creationId xmlns:a16="http://schemas.microsoft.com/office/drawing/2014/main" id="{EBEB2FD8-008C-1AAD-0F38-F290006FFBBA}"/>
+          <p:cNvPr id="6" name="Imagen 5">
+            <a:extLst>
+              <a:ext uri="{FF2B5EF4-FFF2-40B4-BE49-F238E27FC236}">
+                <a16:creationId xmlns:a16="http://schemas.microsoft.com/office/drawing/2014/main" id="{A95E0171-2044-D3B0-03FC-937713CA4B1C}"/>
               </a:ext>
             </a:extLst>
           </p:cNvPr>
@@ -4466,83 +4856,14 @@
               </a:ext>
             </a:extLst>
           </a:blip>
-          <a:srcRect t="13584" b="35196"/>
           <a:stretch>
             <a:fillRect/>
           </a:stretch>
         </p:blipFill>
         <p:spPr>
           <a:xfrm>
-            <a:off x="0" y="0"/>
-            <a:ext cx="12192000" cy="1571952"/>
-          </a:xfrm>
-          <a:prstGeom prst="rect">
-            <a:avLst/>
-          </a:prstGeom>
-        </p:spPr>
-      </p:pic>
-      <p:pic>
-        <p:nvPicPr>
-          <p:cNvPr id="7" name="Imagen 6" descr="Interfaz de usuario gráfica&#10;&#10;El contenido generado por IA puede ser incorrecto.">
-            <a:extLst>
-              <a:ext uri="{FF2B5EF4-FFF2-40B4-BE49-F238E27FC236}">
-                <a16:creationId xmlns:a16="http://schemas.microsoft.com/office/drawing/2014/main" id="{CFAB43E5-2B56-5DC3-8A0B-13E8BA55B867}"/>
-              </a:ext>
-            </a:extLst>
-          </p:cNvPr>
-          <p:cNvPicPr>
-            <a:picLocks noChangeAspect="1"/>
-          </p:cNvPicPr>
-          <p:nvPr/>
-        </p:nvPicPr>
-        <p:blipFill>
-          <a:blip r:embed="rId3">
-            <a:extLst>
-              <a:ext uri="{28A0092B-C50C-407E-A947-70E740481C1C}">
-                <a14:useLocalDpi xmlns:a14="http://schemas.microsoft.com/office/drawing/2010/main" val="0"/>
-              </a:ext>
-            </a:extLst>
-          </a:blip>
-          <a:srcRect t="73915"/>
-          <a:stretch>
-            <a:fillRect/>
-          </a:stretch>
-        </p:blipFill>
-        <p:spPr>
-          <a:xfrm>
-            <a:off x="0" y="5928527"/>
-            <a:ext cx="12192000" cy="929473"/>
-          </a:xfrm>
-          <a:prstGeom prst="rect">
-            <a:avLst/>
-          </a:prstGeom>
-        </p:spPr>
-      </p:pic>
-      <p:pic>
-        <p:nvPicPr>
-          <p:cNvPr id="10" name="Imagen 9" descr="Interfaz de usuario gráfica&#10;&#10;El contenido generado por IA puede ser incorrecto.">
-            <a:extLst>
-              <a:ext uri="{FF2B5EF4-FFF2-40B4-BE49-F238E27FC236}">
-                <a16:creationId xmlns:a16="http://schemas.microsoft.com/office/drawing/2014/main" id="{5F618B0F-5ED3-1810-781E-589DF84C079A}"/>
-              </a:ext>
-            </a:extLst>
-          </p:cNvPr>
-          <p:cNvPicPr>
-            <a:picLocks noChangeAspect="1"/>
-          </p:cNvPicPr>
-          <p:nvPr/>
-        </p:nvPicPr>
-        <p:blipFill>
-          <a:blip r:embed="rId4"/>
-          <a:srcRect t="12661"/>
-          <a:stretch>
-            <a:fillRect/>
-          </a:stretch>
-        </p:blipFill>
-        <p:spPr>
-          <a:xfrm>
-            <a:off x="8832106" y="46298"/>
-            <a:ext cx="2788875" cy="1038024"/>
+            <a:off x="0" y="-11788"/>
+            <a:ext cx="12192000" cy="1611988"/>
           </a:xfrm>
           <a:prstGeom prst="rect">
             <a:avLst/>
@@ -4642,10 +4963,10 @@
       </p:sp>
       <p:pic>
         <p:nvPicPr>
-          <p:cNvPr id="5" name="Imagen 4" descr="Fondo negro con letras blancas&#10;&#10;El contenido generado por IA puede ser incorrecto.">
-            <a:extLst>
-              <a:ext uri="{FF2B5EF4-FFF2-40B4-BE49-F238E27FC236}">
-                <a16:creationId xmlns:a16="http://schemas.microsoft.com/office/drawing/2014/main" id="{95D20443-1AE0-9ED1-9B33-5F0F4A1C220D}"/>
+          <p:cNvPr id="6" name="Imagen 5">
+            <a:extLst>
+              <a:ext uri="{FF2B5EF4-FFF2-40B4-BE49-F238E27FC236}">
+                <a16:creationId xmlns:a16="http://schemas.microsoft.com/office/drawing/2014/main" id="{4DAAC46B-8FE6-1A88-858A-CCA4E536B083}"/>
               </a:ext>
             </a:extLst>
           </p:cNvPr>
@@ -4662,83 +4983,14 @@
               </a:ext>
             </a:extLst>
           </a:blip>
-          <a:srcRect t="13584" b="35196"/>
           <a:stretch>
             <a:fillRect/>
           </a:stretch>
         </p:blipFill>
         <p:spPr>
           <a:xfrm>
-            <a:off x="0" y="0"/>
-            <a:ext cx="12192000" cy="1571952"/>
-          </a:xfrm>
-          <a:prstGeom prst="rect">
-            <a:avLst/>
-          </a:prstGeom>
-        </p:spPr>
-      </p:pic>
-      <p:pic>
-        <p:nvPicPr>
-          <p:cNvPr id="7" name="Imagen 6" descr="Interfaz de usuario gráfica&#10;&#10;El contenido generado por IA puede ser incorrecto.">
-            <a:extLst>
-              <a:ext uri="{FF2B5EF4-FFF2-40B4-BE49-F238E27FC236}">
-                <a16:creationId xmlns:a16="http://schemas.microsoft.com/office/drawing/2014/main" id="{49572B8C-70B2-FD6A-6F1B-5A0AFF73D315}"/>
-              </a:ext>
-            </a:extLst>
-          </p:cNvPr>
-          <p:cNvPicPr>
-            <a:picLocks noChangeAspect="1"/>
-          </p:cNvPicPr>
-          <p:nvPr/>
-        </p:nvPicPr>
-        <p:blipFill>
-          <a:blip r:embed="rId3">
-            <a:extLst>
-              <a:ext uri="{28A0092B-C50C-407E-A947-70E740481C1C}">
-                <a14:useLocalDpi xmlns:a14="http://schemas.microsoft.com/office/drawing/2010/main" val="0"/>
-              </a:ext>
-            </a:extLst>
-          </a:blip>
-          <a:srcRect t="73915"/>
-          <a:stretch>
-            <a:fillRect/>
-          </a:stretch>
-        </p:blipFill>
-        <p:spPr>
-          <a:xfrm>
-            <a:off x="0" y="5928527"/>
-            <a:ext cx="12192000" cy="929473"/>
-          </a:xfrm>
-          <a:prstGeom prst="rect">
-            <a:avLst/>
-          </a:prstGeom>
-        </p:spPr>
-      </p:pic>
-      <p:pic>
-        <p:nvPicPr>
-          <p:cNvPr id="10" name="Imagen 9" descr="Interfaz de usuario gráfica&#10;&#10;El contenido generado por IA puede ser incorrecto.">
-            <a:extLst>
-              <a:ext uri="{FF2B5EF4-FFF2-40B4-BE49-F238E27FC236}">
-                <a16:creationId xmlns:a16="http://schemas.microsoft.com/office/drawing/2014/main" id="{843E2B50-244D-649F-C982-8A849EA3A4CE}"/>
-              </a:ext>
-            </a:extLst>
-          </p:cNvPr>
-          <p:cNvPicPr>
-            <a:picLocks noChangeAspect="1"/>
-          </p:cNvPicPr>
-          <p:nvPr/>
-        </p:nvPicPr>
-        <p:blipFill>
-          <a:blip r:embed="rId4"/>
-          <a:srcRect t="12661"/>
-          <a:stretch>
-            <a:fillRect/>
-          </a:stretch>
-        </p:blipFill>
-        <p:spPr>
-          <a:xfrm>
-            <a:off x="8832106" y="46298"/>
-            <a:ext cx="2788875" cy="1038024"/>
+            <a:off x="0" y="-11788"/>
+            <a:ext cx="12192000" cy="1611988"/>
           </a:xfrm>
           <a:prstGeom prst="rect">
             <a:avLst/>
@@ -4761,6 +5013,14 @@
 <file path=ppt/slides/slide6.xml><?xml version="1.0" encoding="utf-8"?>
 <p:sld xmlns:a="http://schemas.openxmlformats.org/drawingml/2006/main" xmlns:r="http://schemas.openxmlformats.org/officeDocument/2006/relationships" xmlns:p="http://schemas.openxmlformats.org/presentationml/2006/main">
   <p:cSld>
+    <p:bg>
+      <p:bgPr>
+        <a:solidFill>
+          <a:schemeClr val="bg1"/>
+        </a:solidFill>
+        <a:effectLst/>
+      </p:bgPr>
+    </p:bg>
     <p:spTree>
       <p:nvGrpSpPr>
         <p:cNvPr id="1" name="">
@@ -4781,12 +5041,167 @@
           <a:chExt cx="0" cy="0"/>
         </a:xfrm>
       </p:grpSpPr>
+      <p:sp>
+        <p:nvSpPr>
+          <p:cNvPr id="10" name="Rectangle 9">
+            <a:extLst>
+              <a:ext uri="{FF2B5EF4-FFF2-40B4-BE49-F238E27FC236}">
+                <a16:creationId xmlns:a16="http://schemas.microsoft.com/office/drawing/2014/main" id="{42A4FC2C-047E-45A5-965D-8E1E3BF09BC6}"/>
+              </a:ext>
+              <a:ext uri="{C183D7F6-B498-43B3-948B-1728B52AA6E4}">
+                <adec:decorative xmlns:adec="http://schemas.microsoft.com/office/drawing/2017/decorative" val="1"/>
+              </a:ext>
+            </a:extLst>
+          </p:cNvPr>
+          <p:cNvSpPr>
+            <a:spLocks noGrp="1" noRot="1" noChangeAspect="1" noMove="1" noResize="1" noEditPoints="1" noAdjustHandles="1" noChangeArrowheads="1" noChangeShapeType="1" noTextEdit="1"/>
+          </p:cNvSpPr>
+          <p:nvPr>
+            <p:extLst>
+              <p:ext uri="{386F3935-93C4-4BCD-93E2-E3B085C9AB24}">
+                <p16:designElem xmlns:p16="http://schemas.microsoft.com/office/powerpoint/2015/main" val="1"/>
+              </p:ext>
+            </p:extLst>
+          </p:nvPr>
+        </p:nvSpPr>
+        <p:spPr bwMode="white">
+          <a:xfrm>
+            <a:off x="1524" y="0"/>
+            <a:ext cx="12188952" cy="6858000"/>
+          </a:xfrm>
+          <a:prstGeom prst="rect">
+            <a:avLst/>
+          </a:prstGeom>
+          <a:noFill/>
+          <a:ln>
+            <a:noFill/>
+          </a:ln>
+        </p:spPr>
+        <p:style>
+          <a:lnRef idx="2">
+            <a:schemeClr val="accent1">
+              <a:shade val="50000"/>
+            </a:schemeClr>
+          </a:lnRef>
+          <a:fillRef idx="1">
+            <a:schemeClr val="accent1"/>
+          </a:fillRef>
+          <a:effectRef idx="0">
+            <a:schemeClr val="accent1"/>
+          </a:effectRef>
+          <a:fontRef idx="minor">
+            <a:schemeClr val="lt1"/>
+          </a:fontRef>
+        </p:style>
+        <p:txBody>
+          <a:bodyPr rtlCol="0" anchor="ctr"/>
+          <a:lstStyle>
+            <a:defPPr>
+              <a:defRPr lang="en-US"/>
+            </a:defPPr>
+            <a:lvl1pPr marL="0" algn="l" defTabSz="914400" rtl="0" eaLnBrk="1" latinLnBrk="0" hangingPunct="1">
+              <a:defRPr sz="1800" kern="1200">
+                <a:solidFill>
+                  <a:schemeClr val="lt1"/>
+                </a:solidFill>
+                <a:latin typeface="+mn-lt"/>
+                <a:ea typeface="+mn-ea"/>
+                <a:cs typeface="+mn-cs"/>
+              </a:defRPr>
+            </a:lvl1pPr>
+            <a:lvl2pPr marL="457200" algn="l" defTabSz="914400" rtl="0" eaLnBrk="1" latinLnBrk="0" hangingPunct="1">
+              <a:defRPr sz="1800" kern="1200">
+                <a:solidFill>
+                  <a:schemeClr val="lt1"/>
+                </a:solidFill>
+                <a:latin typeface="+mn-lt"/>
+                <a:ea typeface="+mn-ea"/>
+                <a:cs typeface="+mn-cs"/>
+              </a:defRPr>
+            </a:lvl2pPr>
+            <a:lvl3pPr marL="914400" algn="l" defTabSz="914400" rtl="0" eaLnBrk="1" latinLnBrk="0" hangingPunct="1">
+              <a:defRPr sz="1800" kern="1200">
+                <a:solidFill>
+                  <a:schemeClr val="lt1"/>
+                </a:solidFill>
+                <a:latin typeface="+mn-lt"/>
+                <a:ea typeface="+mn-ea"/>
+                <a:cs typeface="+mn-cs"/>
+              </a:defRPr>
+            </a:lvl3pPr>
+            <a:lvl4pPr marL="1371600" algn="l" defTabSz="914400" rtl="0" eaLnBrk="1" latinLnBrk="0" hangingPunct="1">
+              <a:defRPr sz="1800" kern="1200">
+                <a:solidFill>
+                  <a:schemeClr val="lt1"/>
+                </a:solidFill>
+                <a:latin typeface="+mn-lt"/>
+                <a:ea typeface="+mn-ea"/>
+                <a:cs typeface="+mn-cs"/>
+              </a:defRPr>
+            </a:lvl4pPr>
+            <a:lvl5pPr marL="1828800" algn="l" defTabSz="914400" rtl="0" eaLnBrk="1" latinLnBrk="0" hangingPunct="1">
+              <a:defRPr sz="1800" kern="1200">
+                <a:solidFill>
+                  <a:schemeClr val="lt1"/>
+                </a:solidFill>
+                <a:latin typeface="+mn-lt"/>
+                <a:ea typeface="+mn-ea"/>
+                <a:cs typeface="+mn-cs"/>
+              </a:defRPr>
+            </a:lvl5pPr>
+            <a:lvl6pPr marL="2286000" algn="l" defTabSz="914400" rtl="0" eaLnBrk="1" latinLnBrk="0" hangingPunct="1">
+              <a:defRPr sz="1800" kern="1200">
+                <a:solidFill>
+                  <a:schemeClr val="lt1"/>
+                </a:solidFill>
+                <a:latin typeface="+mn-lt"/>
+                <a:ea typeface="+mn-ea"/>
+                <a:cs typeface="+mn-cs"/>
+              </a:defRPr>
+            </a:lvl6pPr>
+            <a:lvl7pPr marL="2743200" algn="l" defTabSz="914400" rtl="0" eaLnBrk="1" latinLnBrk="0" hangingPunct="1">
+              <a:defRPr sz="1800" kern="1200">
+                <a:solidFill>
+                  <a:schemeClr val="lt1"/>
+                </a:solidFill>
+                <a:latin typeface="+mn-lt"/>
+                <a:ea typeface="+mn-ea"/>
+                <a:cs typeface="+mn-cs"/>
+              </a:defRPr>
+            </a:lvl7pPr>
+            <a:lvl8pPr marL="3200400" algn="l" defTabSz="914400" rtl="0" eaLnBrk="1" latinLnBrk="0" hangingPunct="1">
+              <a:defRPr sz="1800" kern="1200">
+                <a:solidFill>
+                  <a:schemeClr val="lt1"/>
+                </a:solidFill>
+                <a:latin typeface="+mn-lt"/>
+                <a:ea typeface="+mn-ea"/>
+                <a:cs typeface="+mn-cs"/>
+              </a:defRPr>
+            </a:lvl8pPr>
+            <a:lvl9pPr marL="3657600" algn="l" defTabSz="914400" rtl="0" eaLnBrk="1" latinLnBrk="0" hangingPunct="1">
+              <a:defRPr sz="1800" kern="1200">
+                <a:solidFill>
+                  <a:schemeClr val="lt1"/>
+                </a:solidFill>
+                <a:latin typeface="+mn-lt"/>
+                <a:ea typeface="+mn-ea"/>
+                <a:cs typeface="+mn-cs"/>
+              </a:defRPr>
+            </a:lvl9pPr>
+          </a:lstStyle>
+          <a:p>
+            <a:pPr algn="ctr"/>
+            <a:endParaRPr lang="en-US"/>
+          </a:p>
+        </p:txBody>
+      </p:sp>
       <p:pic>
         <p:nvPicPr>
-          <p:cNvPr id="6" name="Imagen 5" descr="Interfaz de usuario gráfica, Sitio web&#10;&#10;El contenido generado por IA puede ser incorrecto.">
-            <a:extLst>
-              <a:ext uri="{FF2B5EF4-FFF2-40B4-BE49-F238E27FC236}">
-                <a16:creationId xmlns:a16="http://schemas.microsoft.com/office/drawing/2014/main" id="{6940C7A7-3AB4-2063-194D-CB0539B52538}"/>
+          <p:cNvPr id="5" name="Imagen 4">
+            <a:extLst>
+              <a:ext uri="{FF2B5EF4-FFF2-40B4-BE49-F238E27FC236}">
+                <a16:creationId xmlns:a16="http://schemas.microsoft.com/office/drawing/2014/main" id="{A945A27B-0C11-EE5B-090B-1789BBBD2350}"/>
               </a:ext>
             </a:extLst>
           </p:cNvPr>
@@ -4797,14 +5212,15 @@
         </p:nvPicPr>
         <p:blipFill>
           <a:blip r:embed="rId2"/>
+          <a:srcRect t="1765"/>
           <a:stretch>
             <a:fillRect/>
           </a:stretch>
         </p:blipFill>
         <p:spPr>
           <a:xfrm>
-            <a:off x="0" y="0"/>
-            <a:ext cx="12192000" cy="7100214"/>
+            <a:off x="20" y="1282"/>
+            <a:ext cx="12191980" cy="6856718"/>
           </a:xfrm>
           <a:prstGeom prst="rect">
             <a:avLst/>
@@ -5137,4 +5553,634 @@
     </a:ext>
   </a:extLst>
 </a:theme>
+</file>
+
+<file path=ppt/theme/theme2.xml><?xml version="1.0" encoding="utf-8"?>
+<a:theme xmlns:a="http://schemas.openxmlformats.org/drawingml/2006/main" name="Tema de Office">
+  <a:themeElements>
+    <a:clrScheme name="Office">
+      <a:dk1>
+        <a:sysClr val="windowText" lastClr="000000"/>
+      </a:dk1>
+      <a:lt1>
+        <a:sysClr val="window" lastClr="FFFFFF"/>
+      </a:lt1>
+      <a:dk2>
+        <a:srgbClr val="0E2841"/>
+      </a:dk2>
+      <a:lt2>
+        <a:srgbClr val="E8E8E8"/>
+      </a:lt2>
+      <a:accent1>
+        <a:srgbClr val="156082"/>
+      </a:accent1>
+      <a:accent2>
+        <a:srgbClr val="E97132"/>
+      </a:accent2>
+      <a:accent3>
+        <a:srgbClr val="196B24"/>
+      </a:accent3>
+      <a:accent4>
+        <a:srgbClr val="0F9ED5"/>
+      </a:accent4>
+      <a:accent5>
+        <a:srgbClr val="A02B93"/>
+      </a:accent5>
+      <a:accent6>
+        <a:srgbClr val="4EA72E"/>
+      </a:accent6>
+      <a:hlink>
+        <a:srgbClr val="467886"/>
+      </a:hlink>
+      <a:folHlink>
+        <a:srgbClr val="96607D"/>
+      </a:folHlink>
+    </a:clrScheme>
+    <a:fontScheme name="Office">
+      <a:majorFont>
+        <a:latin typeface="Aptos Display" panose="02110004020202020204"/>
+        <a:ea typeface=""/>
+        <a:cs typeface=""/>
+        <a:font script="Jpan" typeface="游ゴシック Light"/>
+        <a:font script="Hang" typeface="맑은 고딕"/>
+        <a:font script="Hans" typeface="等线 Light"/>
+        <a:font script="Hant" typeface="新細明體"/>
+        <a:font script="Arab" typeface="Times New Roman"/>
+        <a:font script="Hebr" typeface="Times New Roman"/>
+        <a:font script="Thai" typeface="Angsana New"/>
+        <a:font script="Ethi" typeface="Nyala"/>
+        <a:font script="Beng" typeface="Vrinda"/>
+        <a:font script="Gujr" typeface="Shruti"/>
+        <a:font script="Khmr" typeface="MoolBoran"/>
+        <a:font script="Knda" typeface="Tunga"/>
+        <a:font script="Guru" typeface="Raavi"/>
+        <a:font script="Cans" typeface="Euphemia"/>
+        <a:font script="Cher" typeface="Plantagenet Cherokee"/>
+        <a:font script="Yiii" typeface="Microsoft Yi Baiti"/>
+        <a:font script="Tibt" typeface="Microsoft Himalaya"/>
+        <a:font script="Thaa" typeface="MV Boli"/>
+        <a:font script="Deva" typeface="Mangal"/>
+        <a:font script="Telu" typeface="Gautami"/>
+        <a:font script="Taml" typeface="Latha"/>
+        <a:font script="Syrc" typeface="Estrangelo Edessa"/>
+        <a:font script="Orya" typeface="Kalinga"/>
+        <a:font script="Mlym" typeface="Kartika"/>
+        <a:font script="Laoo" typeface="DokChampa"/>
+        <a:font script="Sinh" typeface="Iskoola Pota"/>
+        <a:font script="Mong" typeface="Mongolian Baiti"/>
+        <a:font script="Viet" typeface="Times New Roman"/>
+        <a:font script="Uigh" typeface="Microsoft Uighur"/>
+        <a:font script="Geor" typeface="Sylfaen"/>
+        <a:font script="Armn" typeface="Arial"/>
+        <a:font script="Bugi" typeface="Leelawadee UI"/>
+        <a:font script="Bopo" typeface="Microsoft JhengHei"/>
+        <a:font script="Java" typeface="Javanese Text"/>
+        <a:font script="Lisu" typeface="Segoe UI"/>
+        <a:font script="Mymr" typeface="Myanmar Text"/>
+        <a:font script="Nkoo" typeface="Ebrima"/>
+        <a:font script="Olck" typeface="Nirmala UI"/>
+        <a:font script="Osma" typeface="Ebrima"/>
+        <a:font script="Phag" typeface="Phagspa"/>
+        <a:font script="Syrn" typeface="Estrangelo Edessa"/>
+        <a:font script="Syrj" typeface="Estrangelo Edessa"/>
+        <a:font script="Syre" typeface="Estrangelo Edessa"/>
+        <a:font script="Sora" typeface="Nirmala UI"/>
+        <a:font script="Tale" typeface="Microsoft Tai Le"/>
+        <a:font script="Talu" typeface="Microsoft New Tai Lue"/>
+        <a:font script="Tfng" typeface="Ebrima"/>
+      </a:majorFont>
+      <a:minorFont>
+        <a:latin typeface="Aptos" panose="02110004020202020204"/>
+        <a:ea typeface=""/>
+        <a:cs typeface=""/>
+        <a:font script="Jpan" typeface="游ゴシック"/>
+        <a:font script="Hang" typeface="맑은 고딕"/>
+        <a:font script="Hans" typeface="等线"/>
+        <a:font script="Hant" typeface="新細明體"/>
+        <a:font script="Arab" typeface="Arial"/>
+        <a:font script="Hebr" typeface="Arial"/>
+        <a:font script="Thai" typeface="Cordia New"/>
+        <a:font script="Ethi" typeface="Nyala"/>
+        <a:font script="Beng" typeface="Vrinda"/>
+        <a:font script="Gujr" typeface="Shruti"/>
+        <a:font script="Khmr" typeface="DaunPenh"/>
+        <a:font script="Knda" typeface="Tunga"/>
+        <a:font script="Guru" typeface="Raavi"/>
+        <a:font script="Cans" typeface="Euphemia"/>
+        <a:font script="Cher" typeface="Plantagenet Cherokee"/>
+        <a:font script="Yiii" typeface="Microsoft Yi Baiti"/>
+        <a:font script="Tibt" typeface="Microsoft Himalaya"/>
+        <a:font script="Thaa" typeface="MV Boli"/>
+        <a:font script="Deva" typeface="Mangal"/>
+        <a:font script="Telu" typeface="Gautami"/>
+        <a:font script="Taml" typeface="Latha"/>
+        <a:font script="Syrc" typeface="Estrangelo Edessa"/>
+        <a:font script="Orya" typeface="Kalinga"/>
+        <a:font script="Mlym" typeface="Kartika"/>
+        <a:font script="Laoo" typeface="DokChampa"/>
+        <a:font script="Sinh" typeface="Iskoola Pota"/>
+        <a:font script="Mong" typeface="Mongolian Baiti"/>
+        <a:font script="Viet" typeface="Arial"/>
+        <a:font script="Uigh" typeface="Microsoft Uighur"/>
+        <a:font script="Geor" typeface="Sylfaen"/>
+        <a:font script="Armn" typeface="Arial"/>
+        <a:font script="Bugi" typeface="Leelawadee UI"/>
+        <a:font script="Bopo" typeface="Microsoft JhengHei"/>
+        <a:font script="Java" typeface="Javanese Text"/>
+        <a:font script="Lisu" typeface="Segoe UI"/>
+        <a:font script="Mymr" typeface="Myanmar Text"/>
+        <a:font script="Nkoo" typeface="Ebrima"/>
+        <a:font script="Olck" typeface="Nirmala UI"/>
+        <a:font script="Osma" typeface="Ebrima"/>
+        <a:font script="Phag" typeface="Phagspa"/>
+        <a:font script="Syrn" typeface="Estrangelo Edessa"/>
+        <a:font script="Syrj" typeface="Estrangelo Edessa"/>
+        <a:font script="Syre" typeface="Estrangelo Edessa"/>
+        <a:font script="Sora" typeface="Nirmala UI"/>
+        <a:font script="Tale" typeface="Microsoft Tai Le"/>
+        <a:font script="Talu" typeface="Microsoft New Tai Lue"/>
+        <a:font script="Tfng" typeface="Ebrima"/>
+      </a:minorFont>
+    </a:fontScheme>
+    <a:fmtScheme name="Office">
+      <a:fillStyleLst>
+        <a:solidFill>
+          <a:schemeClr val="phClr"/>
+        </a:solidFill>
+        <a:gradFill rotWithShape="1">
+          <a:gsLst>
+            <a:gs pos="0">
+              <a:schemeClr val="phClr">
+                <a:lumMod val="110000"/>
+                <a:satMod val="105000"/>
+                <a:tint val="67000"/>
+              </a:schemeClr>
+            </a:gs>
+            <a:gs pos="50000">
+              <a:schemeClr val="phClr">
+                <a:lumMod val="105000"/>
+                <a:satMod val="103000"/>
+                <a:tint val="73000"/>
+              </a:schemeClr>
+            </a:gs>
+            <a:gs pos="100000">
+              <a:schemeClr val="phClr">
+                <a:lumMod val="105000"/>
+                <a:satMod val="109000"/>
+                <a:tint val="81000"/>
+              </a:schemeClr>
+            </a:gs>
+          </a:gsLst>
+          <a:lin ang="5400000" scaled="0"/>
+        </a:gradFill>
+        <a:gradFill rotWithShape="1">
+          <a:gsLst>
+            <a:gs pos="0">
+              <a:schemeClr val="phClr">
+                <a:satMod val="103000"/>
+                <a:lumMod val="102000"/>
+                <a:tint val="94000"/>
+              </a:schemeClr>
+            </a:gs>
+            <a:gs pos="50000">
+              <a:schemeClr val="phClr">
+                <a:satMod val="110000"/>
+                <a:lumMod val="100000"/>
+                <a:shade val="100000"/>
+              </a:schemeClr>
+            </a:gs>
+            <a:gs pos="100000">
+              <a:schemeClr val="phClr">
+                <a:lumMod val="99000"/>
+                <a:satMod val="120000"/>
+                <a:shade val="78000"/>
+              </a:schemeClr>
+            </a:gs>
+          </a:gsLst>
+          <a:lin ang="5400000" scaled="0"/>
+        </a:gradFill>
+      </a:fillStyleLst>
+      <a:lnStyleLst>
+        <a:ln w="12700" cap="flat" cmpd="sng" algn="ctr">
+          <a:solidFill>
+            <a:schemeClr val="phClr"/>
+          </a:solidFill>
+          <a:prstDash val="solid"/>
+          <a:miter lim="800000"/>
+        </a:ln>
+        <a:ln w="19050" cap="flat" cmpd="sng" algn="ctr">
+          <a:solidFill>
+            <a:schemeClr val="phClr"/>
+          </a:solidFill>
+          <a:prstDash val="solid"/>
+          <a:miter lim="800000"/>
+        </a:ln>
+        <a:ln w="25400" cap="flat" cmpd="sng" algn="ctr">
+          <a:solidFill>
+            <a:schemeClr val="phClr"/>
+          </a:solidFill>
+          <a:prstDash val="solid"/>
+          <a:miter lim="800000"/>
+        </a:ln>
+      </a:lnStyleLst>
+      <a:effectStyleLst>
+        <a:effectStyle>
+          <a:effectLst/>
+        </a:effectStyle>
+        <a:effectStyle>
+          <a:effectLst/>
+        </a:effectStyle>
+        <a:effectStyle>
+          <a:effectLst>
+            <a:outerShdw blurRad="57150" dist="19050" dir="5400000" algn="ctr" rotWithShape="0">
+              <a:srgbClr val="000000">
+                <a:alpha val="63000"/>
+              </a:srgbClr>
+            </a:outerShdw>
+          </a:effectLst>
+        </a:effectStyle>
+      </a:effectStyleLst>
+      <a:bgFillStyleLst>
+        <a:solidFill>
+          <a:schemeClr val="phClr"/>
+        </a:solidFill>
+        <a:solidFill>
+          <a:schemeClr val="phClr">
+            <a:tint val="95000"/>
+            <a:satMod val="170000"/>
+          </a:schemeClr>
+        </a:solidFill>
+        <a:gradFill rotWithShape="1">
+          <a:gsLst>
+            <a:gs pos="0">
+              <a:schemeClr val="phClr">
+                <a:tint val="93000"/>
+                <a:satMod val="150000"/>
+                <a:shade val="98000"/>
+                <a:lumMod val="102000"/>
+              </a:schemeClr>
+            </a:gs>
+            <a:gs pos="50000">
+              <a:schemeClr val="phClr">
+                <a:tint val="98000"/>
+                <a:satMod val="130000"/>
+                <a:shade val="90000"/>
+                <a:lumMod val="103000"/>
+              </a:schemeClr>
+            </a:gs>
+            <a:gs pos="100000">
+              <a:schemeClr val="phClr">
+                <a:shade val="63000"/>
+                <a:satMod val="120000"/>
+              </a:schemeClr>
+            </a:gs>
+          </a:gsLst>
+          <a:lin ang="5400000" scaled="0"/>
+        </a:gradFill>
+      </a:bgFillStyleLst>
+    </a:fmtScheme>
+  </a:themeElements>
+  <a:objectDefaults>
+    <a:lnDef>
+      <a:spPr/>
+      <a:bodyPr/>
+      <a:lstStyle/>
+      <a:style>
+        <a:lnRef idx="2">
+          <a:schemeClr val="accent1"/>
+        </a:lnRef>
+        <a:fillRef idx="0">
+          <a:schemeClr val="accent1"/>
+        </a:fillRef>
+        <a:effectRef idx="1">
+          <a:schemeClr val="accent1"/>
+        </a:effectRef>
+        <a:fontRef idx="minor">
+          <a:schemeClr val="tx1"/>
+        </a:fontRef>
+      </a:style>
+    </a:lnDef>
+  </a:objectDefaults>
+  <a:extraClrSchemeLst/>
+  <a:extLst>
+    <a:ext uri="{05A4C25C-085E-4340-85A3-A5531E510DB2}">
+      <thm15:themeFamily xmlns:thm15="http://schemas.microsoft.com/office/thememl/2012/main" name="Office Theme" id="{2E142A2C-CD16-42D6-873A-C26D2A0506FA}" vid="{1BDDFF52-6CD6-40A5-AB3C-68EB2F1E4D0A}"/>
+    </a:ext>
+  </a:extLst>
+</a:theme>
+</file>
+
+<file path=ppt/theme/theme3.xml><?xml version="1.0" encoding="utf-8"?>
+<a:theme xmlns:a="http://schemas.openxmlformats.org/drawingml/2006/main" name="Tema de Office">
+  <a:themeElements>
+    <a:clrScheme name="Office">
+      <a:dk1>
+        <a:sysClr val="windowText" lastClr="000000"/>
+      </a:dk1>
+      <a:lt1>
+        <a:sysClr val="window" lastClr="FFFFFF"/>
+      </a:lt1>
+      <a:dk2>
+        <a:srgbClr val="0E2841"/>
+      </a:dk2>
+      <a:lt2>
+        <a:srgbClr val="E8E8E8"/>
+      </a:lt2>
+      <a:accent1>
+        <a:srgbClr val="156082"/>
+      </a:accent1>
+      <a:accent2>
+        <a:srgbClr val="E97132"/>
+      </a:accent2>
+      <a:accent3>
+        <a:srgbClr val="196B24"/>
+      </a:accent3>
+      <a:accent4>
+        <a:srgbClr val="0F9ED5"/>
+      </a:accent4>
+      <a:accent5>
+        <a:srgbClr val="A02B93"/>
+      </a:accent5>
+      <a:accent6>
+        <a:srgbClr val="4EA72E"/>
+      </a:accent6>
+      <a:hlink>
+        <a:srgbClr val="467886"/>
+      </a:hlink>
+      <a:folHlink>
+        <a:srgbClr val="96607D"/>
+      </a:folHlink>
+    </a:clrScheme>
+    <a:fontScheme name="Office">
+      <a:majorFont>
+        <a:latin typeface="Aptos Display" panose="02110004020202020204"/>
+        <a:ea typeface=""/>
+        <a:cs typeface=""/>
+        <a:font script="Jpan" typeface="游ゴシック Light"/>
+        <a:font script="Hang" typeface="맑은 고딕"/>
+        <a:font script="Hans" typeface="等线 Light"/>
+        <a:font script="Hant" typeface="新細明體"/>
+        <a:font script="Arab" typeface="Times New Roman"/>
+        <a:font script="Hebr" typeface="Times New Roman"/>
+        <a:font script="Thai" typeface="Angsana New"/>
+        <a:font script="Ethi" typeface="Nyala"/>
+        <a:font script="Beng" typeface="Vrinda"/>
+        <a:font script="Gujr" typeface="Shruti"/>
+        <a:font script="Khmr" typeface="MoolBoran"/>
+        <a:font script="Knda" typeface="Tunga"/>
+        <a:font script="Guru" typeface="Raavi"/>
+        <a:font script="Cans" typeface="Euphemia"/>
+        <a:font script="Cher" typeface="Plantagenet Cherokee"/>
+        <a:font script="Yiii" typeface="Microsoft Yi Baiti"/>
+        <a:font script="Tibt" typeface="Microsoft Himalaya"/>
+        <a:font script="Thaa" typeface="MV Boli"/>
+        <a:font script="Deva" typeface="Mangal"/>
+        <a:font script="Telu" typeface="Gautami"/>
+        <a:font script="Taml" typeface="Latha"/>
+        <a:font script="Syrc" typeface="Estrangelo Edessa"/>
+        <a:font script="Orya" typeface="Kalinga"/>
+        <a:font script="Mlym" typeface="Kartika"/>
+        <a:font script="Laoo" typeface="DokChampa"/>
+        <a:font script="Sinh" typeface="Iskoola Pota"/>
+        <a:font script="Mong" typeface="Mongolian Baiti"/>
+        <a:font script="Viet" typeface="Times New Roman"/>
+        <a:font script="Uigh" typeface="Microsoft Uighur"/>
+        <a:font script="Geor" typeface="Sylfaen"/>
+        <a:font script="Armn" typeface="Arial"/>
+        <a:font script="Bugi" typeface="Leelawadee UI"/>
+        <a:font script="Bopo" typeface="Microsoft JhengHei"/>
+        <a:font script="Java" typeface="Javanese Text"/>
+        <a:font script="Lisu" typeface="Segoe UI"/>
+        <a:font script="Mymr" typeface="Myanmar Text"/>
+        <a:font script="Nkoo" typeface="Ebrima"/>
+        <a:font script="Olck" typeface="Nirmala UI"/>
+        <a:font script="Osma" typeface="Ebrima"/>
+        <a:font script="Phag" typeface="Phagspa"/>
+        <a:font script="Syrn" typeface="Estrangelo Edessa"/>
+        <a:font script="Syrj" typeface="Estrangelo Edessa"/>
+        <a:font script="Syre" typeface="Estrangelo Edessa"/>
+        <a:font script="Sora" typeface="Nirmala UI"/>
+        <a:font script="Tale" typeface="Microsoft Tai Le"/>
+        <a:font script="Talu" typeface="Microsoft New Tai Lue"/>
+        <a:font script="Tfng" typeface="Ebrima"/>
+      </a:majorFont>
+      <a:minorFont>
+        <a:latin typeface="Aptos" panose="02110004020202020204"/>
+        <a:ea typeface=""/>
+        <a:cs typeface=""/>
+        <a:font script="Jpan" typeface="游ゴシック"/>
+        <a:font script="Hang" typeface="맑은 고딕"/>
+        <a:font script="Hans" typeface="等线"/>
+        <a:font script="Hant" typeface="新細明體"/>
+        <a:font script="Arab" typeface="Arial"/>
+        <a:font script="Hebr" typeface="Arial"/>
+        <a:font script="Thai" typeface="Cordia New"/>
+        <a:font script="Ethi" typeface="Nyala"/>
+        <a:font script="Beng" typeface="Vrinda"/>
+        <a:font script="Gujr" typeface="Shruti"/>
+        <a:font script="Khmr" typeface="DaunPenh"/>
+        <a:font script="Knda" typeface="Tunga"/>
+        <a:font script="Guru" typeface="Raavi"/>
+        <a:font script="Cans" typeface="Euphemia"/>
+        <a:font script="Cher" typeface="Plantagenet Cherokee"/>
+        <a:font script="Yiii" typeface="Microsoft Yi Baiti"/>
+        <a:font script="Tibt" typeface="Microsoft Himalaya"/>
+        <a:font script="Thaa" typeface="MV Boli"/>
+        <a:font script="Deva" typeface="Mangal"/>
+        <a:font script="Telu" typeface="Gautami"/>
+        <a:font script="Taml" typeface="Latha"/>
+        <a:font script="Syrc" typeface="Estrangelo Edessa"/>
+        <a:font script="Orya" typeface="Kalinga"/>
+        <a:font script="Mlym" typeface="Kartika"/>
+        <a:font script="Laoo" typeface="DokChampa"/>
+        <a:font script="Sinh" typeface="Iskoola Pota"/>
+        <a:font script="Mong" typeface="Mongolian Baiti"/>
+        <a:font script="Viet" typeface="Arial"/>
+        <a:font script="Uigh" typeface="Microsoft Uighur"/>
+        <a:font script="Geor" typeface="Sylfaen"/>
+        <a:font script="Armn" typeface="Arial"/>
+        <a:font script="Bugi" typeface="Leelawadee UI"/>
+        <a:font script="Bopo" typeface="Microsoft JhengHei"/>
+        <a:font script="Java" typeface="Javanese Text"/>
+        <a:font script="Lisu" typeface="Segoe UI"/>
+        <a:font script="Mymr" typeface="Myanmar Text"/>
+        <a:font script="Nkoo" typeface="Ebrima"/>
+        <a:font script="Olck" typeface="Nirmala UI"/>
+        <a:font script="Osma" typeface="Ebrima"/>
+        <a:font script="Phag" typeface="Phagspa"/>
+        <a:font script="Syrn" typeface="Estrangelo Edessa"/>
+        <a:font script="Syrj" typeface="Estrangelo Edessa"/>
+        <a:font script="Syre" typeface="Estrangelo Edessa"/>
+        <a:font script="Sora" typeface="Nirmala UI"/>
+        <a:font script="Tale" typeface="Microsoft Tai Le"/>
+        <a:font script="Talu" typeface="Microsoft New Tai Lue"/>
+        <a:font script="Tfng" typeface="Ebrima"/>
+      </a:minorFont>
+    </a:fontScheme>
+    <a:fmtScheme name="Office">
+      <a:fillStyleLst>
+        <a:solidFill>
+          <a:schemeClr val="phClr"/>
+        </a:solidFill>
+        <a:gradFill rotWithShape="1">
+          <a:gsLst>
+            <a:gs pos="0">
+              <a:schemeClr val="phClr">
+                <a:lumMod val="110000"/>
+                <a:satMod val="105000"/>
+                <a:tint val="67000"/>
+              </a:schemeClr>
+            </a:gs>
+            <a:gs pos="50000">
+              <a:schemeClr val="phClr">
+                <a:lumMod val="105000"/>
+                <a:satMod val="103000"/>
+                <a:tint val="73000"/>
+              </a:schemeClr>
+            </a:gs>
+            <a:gs pos="100000">
+              <a:schemeClr val="phClr">
+                <a:lumMod val="105000"/>
+                <a:satMod val="109000"/>
+                <a:tint val="81000"/>
+              </a:schemeClr>
+            </a:gs>
+          </a:gsLst>
+          <a:lin ang="5400000" scaled="0"/>
+        </a:gradFill>
+        <a:gradFill rotWithShape="1">
+          <a:gsLst>
+            <a:gs pos="0">
+              <a:schemeClr val="phClr">
+                <a:satMod val="103000"/>
+                <a:lumMod val="102000"/>
+                <a:tint val="94000"/>
+              </a:schemeClr>
+            </a:gs>
+            <a:gs pos="50000">
+              <a:schemeClr val="phClr">
+                <a:satMod val="110000"/>
+                <a:lumMod val="100000"/>
+                <a:shade val="100000"/>
+              </a:schemeClr>
+            </a:gs>
+            <a:gs pos="100000">
+              <a:schemeClr val="phClr">
+                <a:lumMod val="99000"/>
+                <a:satMod val="120000"/>
+                <a:shade val="78000"/>
+              </a:schemeClr>
+            </a:gs>
+          </a:gsLst>
+          <a:lin ang="5400000" scaled="0"/>
+        </a:gradFill>
+      </a:fillStyleLst>
+      <a:lnStyleLst>
+        <a:ln w="12700" cap="flat" cmpd="sng" algn="ctr">
+          <a:solidFill>
+            <a:schemeClr val="phClr"/>
+          </a:solidFill>
+          <a:prstDash val="solid"/>
+          <a:miter lim="800000"/>
+        </a:ln>
+        <a:ln w="19050" cap="flat" cmpd="sng" algn="ctr">
+          <a:solidFill>
+            <a:schemeClr val="phClr"/>
+          </a:solidFill>
+          <a:prstDash val="solid"/>
+          <a:miter lim="800000"/>
+        </a:ln>
+        <a:ln w="25400" cap="flat" cmpd="sng" algn="ctr">
+          <a:solidFill>
+            <a:schemeClr val="phClr"/>
+          </a:solidFill>
+          <a:prstDash val="solid"/>
+          <a:miter lim="800000"/>
+        </a:ln>
+      </a:lnStyleLst>
+      <a:effectStyleLst>
+        <a:effectStyle>
+          <a:effectLst/>
+        </a:effectStyle>
+        <a:effectStyle>
+          <a:effectLst/>
+        </a:effectStyle>
+        <a:effectStyle>
+          <a:effectLst>
+            <a:outerShdw blurRad="57150" dist="19050" dir="5400000" algn="ctr" rotWithShape="0">
+              <a:srgbClr val="000000">
+                <a:alpha val="63000"/>
+              </a:srgbClr>
+            </a:outerShdw>
+          </a:effectLst>
+        </a:effectStyle>
+      </a:effectStyleLst>
+      <a:bgFillStyleLst>
+        <a:solidFill>
+          <a:schemeClr val="phClr"/>
+        </a:solidFill>
+        <a:solidFill>
+          <a:schemeClr val="phClr">
+            <a:tint val="95000"/>
+            <a:satMod val="170000"/>
+          </a:schemeClr>
+        </a:solidFill>
+        <a:gradFill rotWithShape="1">
+          <a:gsLst>
+            <a:gs pos="0">
+              <a:schemeClr val="phClr">
+                <a:tint val="93000"/>
+                <a:satMod val="150000"/>
+                <a:shade val="98000"/>
+                <a:lumMod val="102000"/>
+              </a:schemeClr>
+            </a:gs>
+            <a:gs pos="50000">
+              <a:schemeClr val="phClr">
+                <a:tint val="98000"/>
+                <a:satMod val="130000"/>
+                <a:shade val="90000"/>
+                <a:lumMod val="103000"/>
+              </a:schemeClr>
+            </a:gs>
+            <a:gs pos="100000">
+              <a:schemeClr val="phClr">
+                <a:shade val="63000"/>
+                <a:satMod val="120000"/>
+              </a:schemeClr>
+            </a:gs>
+          </a:gsLst>
+          <a:lin ang="5400000" scaled="0"/>
+        </a:gradFill>
+      </a:bgFillStyleLst>
+    </a:fmtScheme>
+  </a:themeElements>
+  <a:objectDefaults>
+    <a:lnDef>
+      <a:spPr/>
+      <a:bodyPr/>
+      <a:lstStyle/>
+      <a:style>
+        <a:lnRef idx="2">
+          <a:schemeClr val="accent1"/>
+        </a:lnRef>
+        <a:fillRef idx="0">
+          <a:schemeClr val="accent1"/>
+        </a:fillRef>
+        <a:effectRef idx="1">
+          <a:schemeClr val="accent1"/>
+        </a:effectRef>
+        <a:fontRef idx="minor">
+          <a:schemeClr val="tx1"/>
+        </a:fontRef>
+      </a:style>
+    </a:lnDef>
+  </a:objectDefaults>
+  <a:extraClrSchemeLst/>
+  <a:extLst>
+    <a:ext uri="{05A4C25C-085E-4340-85A3-A5531E510DB2}">
+      <thm15:themeFamily xmlns:thm15="http://schemas.microsoft.com/office/thememl/2012/main" name="Office Theme" id="{2E142A2C-CD16-42D6-873A-C26D2A0506FA}" vid="{1BDDFF52-6CD6-40A5-AB3C-68EB2F1E4D0A}"/>
+    </a:ext>
+  </a:extLst>
+</a:theme>
 </file>
</xml_diff>